<commit_message>
Agri-PV und  Messwerte speichern ergänzt/korrigiert
</commit_message>
<xml_diff>
--- a/2_Sensorik/2.5_Messwerte_speichern/2.5_Messwerte_speichern.pptx
+++ b/2_Sensorik/2.5_Messwerte_speichern/2.5_Messwerte_speichern.pptx
@@ -283,7 +283,7 @@
           <a:p>
             <a:fld id="{028B6593-098D-4382-9647-35487FA190B4}" type="datetimeFigureOut">
               <a:rPr lang="de-DE" smtClean="0"/>
-              <a:t>10.03.2026</a:t>
+              <a:t>20.04.2026</a:t>
             </a:fld>
             <a:endParaRPr lang="de-DE"/>
           </a:p>
@@ -11415,7 +11415,7 @@
         </p:nvSpPr>
         <p:spPr>
           <a:xfrm>
-            <a:off x="717550" y="5690183"/>
+            <a:off x="717550" y="5874849"/>
             <a:ext cx="10790133" cy="369332"/>
           </a:xfrm>
           <a:prstGeom prst="rect">
@@ -11437,6 +11437,41 @@
             <a:r>
               <a:rPr lang="de-DE" smtClean="0"/>
               <a:t>Hinweis: Es kann vorkommen, dass das SD-Kartenmodul an 5V statt 3.3V angeschlossen werden muss.</a:t>
+            </a:r>
+            <a:endParaRPr lang="de-DE"/>
+          </a:p>
+        </p:txBody>
+      </p:sp>
+      <p:sp>
+        <p:nvSpPr>
+          <p:cNvPr id="4" name="Textfeld 3"/>
+          <p:cNvSpPr txBox="1"/>
+          <p:nvPr/>
+        </p:nvSpPr>
+        <p:spPr>
+          <a:xfrm>
+            <a:off x="717550" y="5505517"/>
+            <a:ext cx="3736920" cy="369332"/>
+          </a:xfrm>
+          <a:prstGeom prst="rect">
+            <a:avLst/>
+          </a:prstGeom>
+          <a:noFill/>
+          <a:ln>
+            <a:solidFill>
+              <a:srgbClr val="FF0000"/>
+            </a:solidFill>
+          </a:ln>
+        </p:spPr>
+        <p:txBody>
+          <a:bodyPr wrap="none" rtlCol="0">
+            <a:spAutoFit/>
+          </a:bodyPr>
+          <a:lstStyle/>
+          <a:p>
+            <a:r>
+              <a:rPr lang="de-DE" smtClean="0"/>
+              <a:t>Hinweis: siehe 2.1_Arduino Folie 6</a:t>
             </a:r>
             <a:endParaRPr lang="de-DE"/>
           </a:p>
@@ -12059,41 +12094,6 @@
           </a:p>
         </p:txBody>
       </p:sp>
-      <p:sp>
-        <p:nvSpPr>
-          <p:cNvPr id="12" name="Textfeld 11"/>
-          <p:cNvSpPr txBox="1"/>
-          <p:nvPr/>
-        </p:nvSpPr>
-        <p:spPr>
-          <a:xfrm>
-            <a:off x="717550" y="5690183"/>
-            <a:ext cx="10790133" cy="369332"/>
-          </a:xfrm>
-          <a:prstGeom prst="rect">
-            <a:avLst/>
-          </a:prstGeom>
-          <a:noFill/>
-          <a:ln>
-            <a:solidFill>
-              <a:srgbClr val="FF0000"/>
-            </a:solidFill>
-          </a:ln>
-        </p:spPr>
-        <p:txBody>
-          <a:bodyPr wrap="none" rtlCol="0">
-            <a:spAutoFit/>
-          </a:bodyPr>
-          <a:lstStyle/>
-          <a:p>
-            <a:r>
-              <a:rPr lang="de-DE" smtClean="0"/>
-              <a:t>Hinweis: Es kann vorkommen, dass das SD-Kartenmodul an 5V statt 3.3V angeschlossen werden muss.</a:t>
-            </a:r>
-            <a:endParaRPr lang="de-DE"/>
-          </a:p>
-        </p:txBody>
-      </p:sp>
       <p:pic>
         <p:nvPicPr>
           <p:cNvPr id="4" name="Grafik 3"/>
@@ -12118,6 +12118,76 @@
           </a:prstGeom>
         </p:spPr>
       </p:pic>
+      <p:sp>
+        <p:nvSpPr>
+          <p:cNvPr id="13" name="Textfeld 12"/>
+          <p:cNvSpPr txBox="1"/>
+          <p:nvPr/>
+        </p:nvSpPr>
+        <p:spPr>
+          <a:xfrm>
+            <a:off x="717550" y="5874849"/>
+            <a:ext cx="10790133" cy="369332"/>
+          </a:xfrm>
+          <a:prstGeom prst="rect">
+            <a:avLst/>
+          </a:prstGeom>
+          <a:noFill/>
+          <a:ln>
+            <a:solidFill>
+              <a:srgbClr val="FF0000"/>
+            </a:solidFill>
+          </a:ln>
+        </p:spPr>
+        <p:txBody>
+          <a:bodyPr wrap="none" rtlCol="0">
+            <a:spAutoFit/>
+          </a:bodyPr>
+          <a:lstStyle/>
+          <a:p>
+            <a:r>
+              <a:rPr lang="de-DE" smtClean="0"/>
+              <a:t>Hinweis: Es kann vorkommen, dass das SD-Kartenmodul an 5V statt 3.3V angeschlossen werden muss.</a:t>
+            </a:r>
+            <a:endParaRPr lang="de-DE"/>
+          </a:p>
+        </p:txBody>
+      </p:sp>
+      <p:sp>
+        <p:nvSpPr>
+          <p:cNvPr id="14" name="Textfeld 13"/>
+          <p:cNvSpPr txBox="1"/>
+          <p:nvPr/>
+        </p:nvSpPr>
+        <p:spPr>
+          <a:xfrm>
+            <a:off x="717550" y="5505517"/>
+            <a:ext cx="3736920" cy="369332"/>
+          </a:xfrm>
+          <a:prstGeom prst="rect">
+            <a:avLst/>
+          </a:prstGeom>
+          <a:noFill/>
+          <a:ln>
+            <a:solidFill>
+              <a:srgbClr val="FF0000"/>
+            </a:solidFill>
+          </a:ln>
+        </p:spPr>
+        <p:txBody>
+          <a:bodyPr wrap="none" rtlCol="0">
+            <a:spAutoFit/>
+          </a:bodyPr>
+          <a:lstStyle/>
+          <a:p>
+            <a:r>
+              <a:rPr lang="de-DE" smtClean="0"/>
+              <a:t>Hinweis: siehe 2.1_Arduino Folie 6</a:t>
+            </a:r>
+            <a:endParaRPr lang="de-DE"/>
+          </a:p>
+        </p:txBody>
+      </p:sp>
     </p:spTree>
     <p:extLst>
       <p:ext uri="{BB962C8B-B14F-4D97-AF65-F5344CB8AC3E}">
@@ -15979,21 +16049,6 @@
 </file>
 
 <file path=customXml/item1.xml><?xml version="1.0" encoding="utf-8"?>
-<?mso-contentType ?>
-<FormTemplates xmlns="http://schemas.microsoft.com/sharepoint/v3/contenttype/forms">
-  <Display>DocumentLibraryForm</Display>
-  <Edit>DocumentLibraryForm</Edit>
-  <New>DocumentLibraryForm</New>
-</FormTemplates>
-</file>
-
-<file path=customXml/item2.xml><?xml version="1.0" encoding="utf-8"?>
-<p:properties xmlns:p="http://schemas.microsoft.com/office/2006/metadata/properties" xmlns:xsi="http://www.w3.org/2001/XMLSchema-instance" xmlns:pc="http://schemas.microsoft.com/office/infopath/2007/PartnerControls">
-  <documentManagement/>
-</p:properties>
-</file>
-
-<file path=customXml/item3.xml><?xml version="1.0" encoding="utf-8"?>
 <ct:contentTypeSchema xmlns:ct="http://schemas.microsoft.com/office/2006/metadata/contentType" xmlns:ma="http://schemas.microsoft.com/office/2006/metadata/properties/metaAttributes" ct:_="" ma:_="" ma:contentTypeName="Dokument" ma:contentTypeID="0x0101005DA79B272C4D3C4887957B2C2A69604C" ma:contentTypeVersion="2" ma:contentTypeDescription="Ein neues Dokument erstellen." ma:contentTypeScope="" ma:versionID="a8f11939e8f693b5e60eead0cd42f230">
   <xsd:schema xmlns:xsd="http://www.w3.org/2001/XMLSchema" xmlns:xs="http://www.w3.org/2001/XMLSchema" xmlns:p="http://schemas.microsoft.com/office/2006/metadata/properties" xmlns:ns2="99f41258-1f02-46b6-b230-447d6494c4cb" targetNamespace="http://schemas.microsoft.com/office/2006/metadata/properties" ma:root="true" ma:fieldsID="be05fa88f11a9855f776efdf4611a3d7" ns2:_="">
     <xsd:import namespace="99f41258-1f02-46b6-b230-447d6494c4cb"/>
@@ -16141,10 +16196,35 @@
 </ct:contentTypeSchema>
 </file>
 
+<file path=customXml/item2.xml><?xml version="1.0" encoding="utf-8"?>
+<p:properties xmlns:p="http://schemas.microsoft.com/office/2006/metadata/properties" xmlns:xsi="http://www.w3.org/2001/XMLSchema-instance" xmlns:pc="http://schemas.microsoft.com/office/infopath/2007/PartnerControls">
+  <documentManagement/>
+</p:properties>
+</file>
+
+<file path=customXml/item3.xml><?xml version="1.0" encoding="utf-8"?>
+<?mso-contentType ?>
+<FormTemplates xmlns="http://schemas.microsoft.com/sharepoint/v3/contenttype/forms">
+  <Display>DocumentLibraryForm</Display>
+  <Edit>DocumentLibraryForm</Edit>
+  <New>DocumentLibraryForm</New>
+</FormTemplates>
+</file>
+
 <file path=customXml/itemProps1.xml><?xml version="1.0" encoding="utf-8"?>
-<ds:datastoreItem xmlns:ds="http://schemas.openxmlformats.org/officeDocument/2006/customXml" ds:itemID="{AE15DEB7-8D29-4EC4-857C-8778EFE70922}">
+<ds:datastoreItem xmlns:ds="http://schemas.openxmlformats.org/officeDocument/2006/customXml" ds:itemID="{DF333B2F-1563-4DC4-B635-64824C2FC330}">
   <ds:schemaRefs>
-    <ds:schemaRef ds:uri="http://schemas.microsoft.com/sharepoint/v3/contenttype/forms"/>
+    <ds:schemaRef ds:uri="http://schemas.microsoft.com/office/2006/metadata/contentType"/>
+    <ds:schemaRef ds:uri="http://schemas.microsoft.com/office/2006/metadata/properties/metaAttributes"/>
+    <ds:schemaRef ds:uri="http://www.w3.org/2001/XMLSchema"/>
+    <ds:schemaRef ds:uri="http://schemas.microsoft.com/office/2006/metadata/properties"/>
+    <ds:schemaRef ds:uri="99f41258-1f02-46b6-b230-447d6494c4cb"/>
+    <ds:schemaRef ds:uri="http://schemas.microsoft.com/office/2006/documentManagement/types"/>
+    <ds:schemaRef ds:uri="http://schemas.microsoft.com/office/infopath/2007/PartnerControls"/>
+    <ds:schemaRef ds:uri="http://schemas.openxmlformats.org/package/2006/metadata/core-properties"/>
+    <ds:schemaRef ds:uri="http://purl.org/dc/elements/1.1/"/>
+    <ds:schemaRef ds:uri="http://purl.org/dc/terms/"/>
+    <ds:schemaRef ds:uri="http://schemas.microsoft.com/internal/obd"/>
   </ds:schemaRefs>
 </ds:datastoreItem>
 </file>
@@ -16166,19 +16246,9 @@
 </file>
 
 <file path=customXml/itemProps3.xml><?xml version="1.0" encoding="utf-8"?>
-<ds:datastoreItem xmlns:ds="http://schemas.openxmlformats.org/officeDocument/2006/customXml" ds:itemID="{DF333B2F-1563-4DC4-B635-64824C2FC330}">
+<ds:datastoreItem xmlns:ds="http://schemas.openxmlformats.org/officeDocument/2006/customXml" ds:itemID="{AE15DEB7-8D29-4EC4-857C-8778EFE70922}">
   <ds:schemaRefs>
-    <ds:schemaRef ds:uri="http://schemas.microsoft.com/office/2006/metadata/contentType"/>
-    <ds:schemaRef ds:uri="http://schemas.microsoft.com/office/2006/metadata/properties/metaAttributes"/>
-    <ds:schemaRef ds:uri="http://www.w3.org/2001/XMLSchema"/>
-    <ds:schemaRef ds:uri="http://schemas.microsoft.com/office/2006/metadata/properties"/>
-    <ds:schemaRef ds:uri="99f41258-1f02-46b6-b230-447d6494c4cb"/>
-    <ds:schemaRef ds:uri="http://schemas.microsoft.com/office/2006/documentManagement/types"/>
-    <ds:schemaRef ds:uri="http://schemas.microsoft.com/office/infopath/2007/PartnerControls"/>
-    <ds:schemaRef ds:uri="http://schemas.openxmlformats.org/package/2006/metadata/core-properties"/>
-    <ds:schemaRef ds:uri="http://purl.org/dc/elements/1.1/"/>
-    <ds:schemaRef ds:uri="http://purl.org/dc/terms/"/>
-    <ds:schemaRef ds:uri="http://schemas.microsoft.com/internal/obd"/>
+    <ds:schemaRef ds:uri="http://schemas.microsoft.com/sharepoint/v3/contenttype/forms"/>
   </ds:schemaRefs>
 </ds:datastoreItem>
 </file>
</xml_diff>